<commit_message>
Add Team Aero Flash (Vaibhav, Subham Kumar) to submission PDF and deck
</commit_message>
<xml_diff>
--- a/deck/PlantBrain_Pitch.pptx
+++ b/deck/PlantBrain_Pitch.pptx
@@ -2123,7 +2123,7 @@
         </p:nvSpPr>
         <p:spPr>
           <a:xfrm>
-            <a:off x="4453128" y="5029200"/>
+            <a:off x="4453128" y="4892040"/>
             <a:ext cx="3291840" cy="566928"/>
           </a:xfrm>
           <a:prstGeom prst="roundRect">
@@ -2150,7 +2150,7 @@
         </p:nvSpPr>
         <p:spPr>
           <a:xfrm>
-            <a:off x="4453128" y="5029200"/>
+            <a:off x="4453128" y="4892040"/>
             <a:ext cx="3291840" cy="566928"/>
           </a:xfrm>
           <a:prstGeom prst="rect">
@@ -2178,6 +2178,45 @@
               <a:t>Live working prototype inside</a:t>
             </a:r>
             <a:endParaRPr lang="en-US" sz="1350" dirty="0"/>
+          </a:p>
+        </p:txBody>
+      </p:sp>
+      <p:sp>
+        <p:nvSpPr>
+          <p:cNvPr id="8" name="Text 6"/>
+          <p:cNvSpPr/>
+          <p:nvPr/>
+        </p:nvSpPr>
+        <p:spPr>
+          <a:xfrm>
+            <a:off x="0" y="5806440"/>
+            <a:ext cx="12191695" cy="365760"/>
+          </a:xfrm>
+          <a:prstGeom prst="rect">
+            <a:avLst/>
+          </a:prstGeom>
+          <a:noFill/>
+          <a:ln/>
+        </p:spPr>
+        <p:txBody>
+          <a:bodyPr wrap="square" lIns="0" tIns="0" rIns="0" bIns="0" rtlCol="0" anchor="ctr"/>
+          <a:lstStyle/>
+          <a:p>
+            <a:pPr algn="ctr" indent="0" marL="0">
+              <a:buNone/>
+            </a:pPr>
+            <a:r>
+              <a:rPr lang="en-US" sz="1400" b="1" dirty="0">
+                <a:solidFill>
+                  <a:srgbClr val="C9D4DE"/>
+                </a:solidFill>
+                <a:latin typeface="Arial" pitchFamily="34" charset="0"/>
+                <a:ea typeface="Arial" pitchFamily="34" charset="-122"/>
+                <a:cs typeface="Arial" pitchFamily="34" charset="-120"/>
+              </a:rPr>
+              <a:t>Team Aero Flash  —  Vaibhav  ·  Subham Kumar</a:t>
+            </a:r>
+            <a:endParaRPr lang="en-US" sz="1400" dirty="0"/>
           </a:p>
         </p:txBody>
       </p:sp>
@@ -2299,7 +2338,7 @@
         </p:nvSpPr>
         <p:spPr>
           <a:xfrm>
-            <a:off x="0" y="5120640"/>
+            <a:off x="0" y="4892040"/>
             <a:ext cx="12191695" cy="365760"/>
           </a:xfrm>
           <a:prstGeom prst="rect">
@@ -2316,7 +2355,46 @@
               <a:buNone/>
             </a:pPr>
             <a:r>
-              <a:rPr lang="en-US" sz="1300" dirty="0">
+              <a:rPr lang="en-US" sz="1500" b="1" dirty="0">
+                <a:solidFill>
+                  <a:srgbClr val="C9D4DE"/>
+                </a:solidFill>
+                <a:latin typeface="Arial" pitchFamily="34" charset="0"/>
+                <a:ea typeface="Arial" pitchFamily="34" charset="-122"/>
+                <a:cs typeface="Arial" pitchFamily="34" charset="-120"/>
+              </a:rPr>
+              <a:t>Team Aero Flash  —  Vaibhav  ·  Subham Kumar</a:t>
+            </a:r>
+            <a:endParaRPr lang="en-US" sz="1500" dirty="0"/>
+          </a:p>
+        </p:txBody>
+      </p:sp>
+      <p:sp>
+        <p:nvSpPr>
+          <p:cNvPr id="5" name="Text 3"/>
+          <p:cNvSpPr/>
+          <p:nvPr/>
+        </p:nvSpPr>
+        <p:spPr>
+          <a:xfrm>
+            <a:off x="0" y="5349240"/>
+            <a:ext cx="12191695" cy="365760"/>
+          </a:xfrm>
+          <a:prstGeom prst="rect">
+            <a:avLst/>
+          </a:prstGeom>
+          <a:noFill/>
+          <a:ln/>
+        </p:spPr>
+        <p:txBody>
+          <a:bodyPr wrap="square" lIns="0" tIns="0" rIns="0" bIns="0" rtlCol="0" anchor="ctr"/>
+          <a:lstStyle/>
+          <a:p>
+            <a:pPr algn="ctr" indent="0" marL="0">
+              <a:buNone/>
+            </a:pPr>
+            <a:r>
+              <a:rPr lang="en-US" sz="1250" dirty="0">
                 <a:solidFill>
                   <a:srgbClr val="8FA0B0"/>
                 </a:solidFill>
@@ -2326,7 +2404,7 @@
               </a:rPr>
               <a:t>PlantBrain  ·  live demo available  ·  built for ET AI Hackathon 2026</a:t>
             </a:r>
-            <a:endParaRPr lang="en-US" sz="1300" dirty="0"/>
+            <a:endParaRPr lang="en-US" sz="1250" dirty="0"/>
           </a:p>
         </p:txBody>
       </p:sp>

</xml_diff>

<commit_message>
Add team name to deck and submission PDF; add video script
</commit_message>
<xml_diff>
--- a/deck/PlantBrain_Pitch.pptx
+++ b/deck/PlantBrain_Pitch.pptx
@@ -2214,7 +2214,7 @@
                 <a:ea typeface="Arial" pitchFamily="34" charset="-122"/>
                 <a:cs typeface="Arial" pitchFamily="34" charset="-120"/>
               </a:rPr>
-              <a:t>Team Aero Flash  —  Vaibhav  ·  Subham Kumar</a:t>
+              <a:t>Team justvaibhavyadav  —  Vaibhav  ·  Subham Kumar</a:t>
             </a:r>
             <a:endParaRPr lang="en-US" sz="1400" dirty="0"/>
           </a:p>
@@ -2363,7 +2363,7 @@
                 <a:ea typeface="Arial" pitchFamily="34" charset="-122"/>
                 <a:cs typeface="Arial" pitchFamily="34" charset="-120"/>
               </a:rPr>
-              <a:t>Team Aero Flash  —  Vaibhav  ·  Subham Kumar</a:t>
+              <a:t>Team justvaibhavyadav  —  Vaibhav  ·  Subham Kumar</a:t>
             </a:r>
             <a:endParaRPr lang="en-US" sz="1500" dirty="0"/>
           </a:p>

</xml_diff>